<commit_message>
Dataset dibersihkan (257 potongan OCR rusak dibuang), dibagi train/validation/test per produk; model dilatih ulang, test 84,7%, validasi 10/10
</commit_message>
<xml_diff>
--- a/presentasi/ScanBite.pptx
+++ b/presentasi/ScanBite.pptx
@@ -3240,7 +3240,7 @@
                 <a:ea typeface="Georgia" pitchFamily="34" charset="-122"/>
                 <a:cs typeface="Georgia" pitchFamily="34" charset="-120"/>
               </a:rPr>
-              <a:t>Label kemasan mencampur bahan dengan peringatan. Mencocokkan kata saja tidak cukup: kalimatnya perlu dipilah dulu. Model kami benar 90,4% di 230 kalimat uji.</a:t>
+              <a:t>Label kemasan mencampur bahan dengan peringatan. Mencocokkan kata saja tidak cukup: kalimatnya perlu dipilah dulu. Model kami benar 84,7% di 144 kalimat test.</a:t>
             </a:r>
             <a:endParaRPr lang="en-US" sz="1900" dirty="0"/>
           </a:p>
@@ -3831,7 +3831,7 @@
                 <a:ea typeface="Calibri" pitchFamily="34" charset="-122"/>
                 <a:cs typeface="Calibri" pitchFamily="34" charset="-120"/>
               </a:rPr>
-              <a:t>Data latih dan uji sekarang berasal dari 230 foto Open Food Facts. Kamera iPhone di rak toko memberi sudut, cahaya, dan pantulan yang belum pernah dilihat model.</a:t>
+              <a:t>Data latih dan uji sekarang berasal dari foto Open Food Facts. Kamera iPhone di rak toko memberi sudut, cahaya, dan pantulan yang belum pernah dilihat model.</a:t>
             </a:r>
             <a:endParaRPr lang="en-US" sz="1600" dirty="0"/>
           </a:p>
@@ -6863,7 +6863,7 @@
                 <a:ea typeface="Calibri" pitchFamily="34" charset="-122"/>
                 <a:cs typeface="Calibri" pitchFamily="34" charset="-120"/>
               </a:rPr>
-              <a:t>Model buatan kami memilah tiap kalimat: bahan, peringatan “dapat mengandung”, atau lain. Dilatih dari 1.197 kalimat 220 label sungguhan.</a:t>
+              <a:t>Model buatan kami memilah tiap kalimat: bahan, peringatan “dapat mengandung”, atau lain. Dilatih dari 940 kalimat 206 label sungguhan, akurasi test 84,7%.</a:t>
             </a:r>
             <a:endParaRPr lang="en-US" sz="1350" dirty="0"/>
           </a:p>

</xml_diff>

<commit_message>
Latih ulang dengan kalimat tanpa judul; pengaman tebakan peringatan; test 85,9%
</commit_message>
<xml_diff>
--- a/presentasi/ScanBite.pptx
+++ b/presentasi/ScanBite.pptx
@@ -3240,7 +3240,7 @@
                 <a:ea typeface="Georgia" pitchFamily="34" charset="-122"/>
                 <a:cs typeface="Georgia" pitchFamily="34" charset="-120"/>
               </a:rPr>
-              <a:t>Label kemasan mencampur bahan dengan peringatan. Mencocokkan kata saja tidak cukup: kalimatnya perlu dipilah dulu. Model kami benar 84,7% di 144 kalimat test.</a:t>
+              <a:t>Label kemasan mencampur bahan dengan peringatan. Mencocokkan kata saja tidak cukup: kalimatnya perlu dipilah dulu. Model kami benar 85,9% di 170 kalimat test.</a:t>
             </a:r>
             <a:endParaRPr lang="en-US" sz="1900" dirty="0"/>
           </a:p>
@@ -6863,7 +6863,7 @@
                 <a:ea typeface="Calibri" pitchFamily="34" charset="-122"/>
                 <a:cs typeface="Calibri" pitchFamily="34" charset="-120"/>
               </a:rPr>
-              <a:t>Model buatan kami memilah tiap kalimat: bahan, peringatan “dapat mengandung”, atau lain. Dilatih dari 940 kalimat 206 label sungguhan, akurasi test 84,7%.</a:t>
+              <a:t>Model buatan kami memilah tiap kalimat: bahan, peringatan “dapat mengandung”, atau lain. Dilatih dari 940 kalimat 206 label sungguhan, akurasi test 85,9%.</a:t>
             </a:r>
             <a:endParaRPr lang="en-US" sz="1350" dirty="0"/>
           </a:p>

</xml_diff>

<commit_message>
Sebut model kustom PemilahKalimat (dilatih dengan Create ML)
</commit_message>
<xml_diff>
--- a/presentasi/ScanBite.pptx
+++ b/presentasi/ScanBite.pptx
@@ -1306,7 +1306,7 @@
           <a:p>
             <a:r>
               <a:rPr lang="en-US" dirty="0"/>
-              <a:t>Dua fitur diajarkan (Create ML, Foundation Models) dan satu dari side-app (baca teks dari foto). Semuanya jalan di perangkat.</a:t>
+              <a:t>Dua fitur diajarkan (model kustom PemilahKalimat dari Create ML, dan Foundation Models) dan satu dari side-app (baca teks dari foto). Semuanya jalan di perangkat.</a:t>
             </a:r>
             <a:endParaRPr lang="en-US" dirty="0"/>
           </a:p>
@@ -6785,7 +6785,7 @@
                 <a:ea typeface="Calibri" pitchFamily="34" charset="-122"/>
                 <a:cs typeface="Calibri" pitchFamily="34" charset="-120"/>
               </a:rPr>
-              <a:t>Diajarkan  ·  sesi 1.3</a:t>
+              <a:t>Diajarkan  ·  sesi 1.3  ·  Create ML</a:t>
             </a:r>
             <a:endParaRPr lang="en-US" sz="1100" dirty="0"/>
           </a:p>
@@ -6824,7 +6824,7 @@
                 <a:ea typeface="Georgia" pitchFamily="34" charset="-122"/>
                 <a:cs typeface="Georgia" pitchFamily="34" charset="-120"/>
               </a:rPr>
-              <a:t>Create ML</a:t>
+              <a:t>Model kustom: PemilahKalimat</a:t>
             </a:r>
             <a:endParaRPr lang="en-US" sz="1900" dirty="0"/>
           </a:p>
@@ -6863,7 +6863,7 @@
                 <a:ea typeface="Calibri" pitchFamily="34" charset="-122"/>
                 <a:cs typeface="Calibri" pitchFamily="34" charset="-120"/>
               </a:rPr>
-              <a:t>Model buatan kami memilah tiap kalimat: bahan, peringatan “dapat mengandung”, atau lain. Dilatih dari 940 kalimat 206 label sungguhan, akurasi test 85,9%.</a:t>
+              <a:t>Model buatan kami, dilatih dengan Create ML. Memilah tiap kalimat: bahan, peringatan “dapat mengandung”, atau lain. Dilatih dari 940 kalimat 206 label sungguhan, akurasi test 85,9%.</a:t>
             </a:r>
             <a:endParaRPr lang="en-US" sz="1350" dirty="0"/>
           </a:p>

</xml_diff>